<commit_message>
Use official KC logo lockup on deck covers; keep white backgrounds
公式ロゴ（マーク＋KASUMIGASEKI CAPITAL 2段セリフ）を忠実に再現した
kc_logo.png を作成し、両資料（稟議・Lunest）の表紙ロゴに反映。
背景は全ページ白で統一済み。

- slides/assets/kc_logo.png / make_logo.mjs（ロゴ生成）
- 稟議・Lunest 両デッキの表紙を公式ロゴロックアップに差し替え

Co-Authored-By: Claude Opus 4.8 <noreply@anthropic.com>
Claude-Session: https://claude.ai/code/session_0137o3FtbMbDL2jU3XqfZNpe
</commit_message>
<xml_diff>
--- a/slides/Lunest_事業性評価_KC.pptx
+++ b/slides/Lunest_事業性評価_KC.pptx
@@ -3556,7 +3556,7 @@
       </p:grpSpPr>
       <p:pic>
         <p:nvPicPr>
-          <p:cNvPr id="2" name="Image 0" descr="kc_mark.png">    </p:cNvPr>
+          <p:cNvPr id="2" name="Image 0" descr="kc_logo.png">    </p:cNvPr>
           <p:cNvPicPr>
             <a:picLocks noChangeAspect="1"/>
           </p:cNvPicPr>
@@ -3570,8 +3570,8 @@
         </p:blipFill>
         <p:spPr>
           <a:xfrm>
-            <a:off x="640080" y="502920"/>
-            <a:ext cx="252374" cy="301798"/>
+            <a:off x="640080" y="457200"/>
+            <a:ext cx="2148840" cy="576072"/>
           </a:xfrm>
           <a:prstGeom prst="rect">
             <a:avLst/>
@@ -3581,45 +3581,6 @@
       <p:sp>
         <p:nvSpPr>
           <p:cNvPr id="3" name="Text 0"/>
-          <p:cNvSpPr/>
-          <p:nvPr/>
-        </p:nvSpPr>
-        <p:spPr>
-          <a:xfrm>
-            <a:off x="955548" y="471373"/>
-            <a:ext cx="2377440" cy="357530"/>
-          </a:xfrm>
-          <a:prstGeom prst="rect">
-            <a:avLst/>
-          </a:prstGeom>
-          <a:noFill/>
-          <a:ln/>
-        </p:spPr>
-        <p:txBody>
-          <a:bodyPr wrap="square" lIns="0" tIns="0" rIns="0" bIns="0" rtlCol="0" anchor="ctr"/>
-          <a:lstStyle/>
-          <a:p>
-            <a:pPr indent="0" marL="0">
-              <a:buNone/>
-            </a:pPr>
-            <a:r>
-              <a:rPr lang="en-US" sz="1035" spc="120" kern="0" dirty="0">
-                <a:solidFill>
-                  <a:srgbClr val="1A1A1A"/>
-                </a:solidFill>
-                <a:latin typeface="Times New Roman" pitchFamily="34" charset="0"/>
-                <a:ea typeface="Times New Roman" pitchFamily="34" charset="-122"/>
-                <a:cs typeface="Times New Roman" pitchFamily="34" charset="-120"/>
-              </a:rPr>
-              <a:t>KASUMIGASEKI CAPITAL</a:t>
-            </a:r>
-            <a:endParaRPr lang="en-US" sz="1035" dirty="0"/>
-          </a:p>
-        </p:txBody>
-      </p:sp>
-      <p:sp>
-        <p:nvSpPr>
-          <p:cNvPr id="4" name="Text 1"/>
           <p:cNvSpPr/>
           <p:nvPr/>
         </p:nvSpPr>
@@ -3658,7 +3619,7 @@
       </p:sp>
       <p:sp>
         <p:nvSpPr>
-          <p:cNvPr id="5" name="Text 2"/>
+          <p:cNvPr id="4" name="Text 1"/>
           <p:cNvSpPr/>
           <p:nvPr/>
         </p:nvSpPr>
@@ -3697,7 +3658,7 @@
       </p:sp>
       <p:sp>
         <p:nvSpPr>
-          <p:cNvPr id="6" name="Text 3"/>
+          <p:cNvPr id="5" name="Text 2"/>
           <p:cNvSpPr/>
           <p:nvPr/>
         </p:nvSpPr>
@@ -3736,7 +3697,7 @@
       </p:sp>
       <p:sp>
         <p:nvSpPr>
-          <p:cNvPr id="7" name="Shape 4"/>
+          <p:cNvPr id="6" name="Shape 3"/>
           <p:cNvSpPr/>
           <p:nvPr/>
         </p:nvSpPr>
@@ -3759,7 +3720,7 @@
       </p:sp>
       <p:sp>
         <p:nvSpPr>
-          <p:cNvPr id="8" name="Text 5"/>
+          <p:cNvPr id="7" name="Text 4"/>
           <p:cNvSpPr/>
           <p:nvPr/>
         </p:nvSpPr>
@@ -3841,7 +3802,7 @@
       </p:sp>
       <p:sp>
         <p:nvSpPr>
-          <p:cNvPr id="9" name="Text 6"/>
+          <p:cNvPr id="8" name="Text 5"/>
           <p:cNvSpPr/>
           <p:nvPr/>
         </p:nvSpPr>

</xml_diff>